<commit_message>
Fix .pptx that Google Slides refused to open
Two hand-written XML bits violated the OOXML element sequence. PowerPoint
tolerates both; Google Slides validates strictly and rejects the file.

- the round face crops appended a second <a:prstGeom>, leaving two
  geometries in one <a:spPr> (8 shapes)
- table cell borders were appended after the fill; CT_TableCellProperties
  requires lnL/lnR/lnT/lnB before the fill (144 cells)

152 problems -> 0. The build now validates its own output and refuses to
write the file at all if any schema problem remains, so this cannot ship
again.

Co-Authored-By: Claude <noreply@anthropic.com>
</commit_message>
<xml_diff>
--- a/decks/PowerToFly-GTM-Sales-Deck.pptx
+++ b/decks/PowerToFly-GTM-Sales-Deck.pptx
@@ -14474,14 +14474,14 @@
                     </a:p>
                   </a:txBody>
                   <a:tcPr>
-                    <a:solidFill>
-                      <a:srgbClr val="FFFFFF"/>
-                    </a:solidFill>
                     <a:lnB w="9525" cap="flat">
                       <a:solidFill>
                         <a:srgbClr val="E7E7E5"/>
                       </a:solidFill>
                     </a:lnB>
+                    <a:solidFill>
+                      <a:srgbClr val="FFFFFF"/>
+                    </a:solidFill>
                   </a:tcPr>
                 </a:tc>
                 <a:tc>
@@ -14512,14 +14512,14 @@
                     </a:p>
                   </a:txBody>
                   <a:tcPr>
-                    <a:solidFill>
-                      <a:srgbClr val="FFFFFF"/>
-                    </a:solidFill>
                     <a:lnB w="9525" cap="flat">
                       <a:solidFill>
                         <a:srgbClr val="E7E7E5"/>
                       </a:solidFill>
                     </a:lnB>
+                    <a:solidFill>
+                      <a:srgbClr val="FFFFFF"/>
+                    </a:solidFill>
                   </a:tcPr>
                 </a:tc>
                 <a:tc>
@@ -14550,14 +14550,14 @@
                     </a:p>
                   </a:txBody>
                   <a:tcPr>
-                    <a:solidFill>
-                      <a:srgbClr val="FFFFFF"/>
-                    </a:solidFill>
                     <a:lnB w="9525" cap="flat">
                       <a:solidFill>
                         <a:srgbClr val="E7E7E5"/>
                       </a:solidFill>
                     </a:lnB>
+                    <a:solidFill>
+                      <a:srgbClr val="FFFFFF"/>
+                    </a:solidFill>
                   </a:tcPr>
                 </a:tc>
                 <a:tc>
@@ -14588,14 +14588,14 @@
                     </a:p>
                   </a:txBody>
                   <a:tcPr>
-                    <a:solidFill>
-                      <a:srgbClr val="FFFFFF"/>
-                    </a:solidFill>
                     <a:lnB w="9525" cap="flat">
                       <a:solidFill>
                         <a:srgbClr val="E7E7E5"/>
                       </a:solidFill>
                     </a:lnB>
+                    <a:solidFill>
+                      <a:srgbClr val="FFFFFF"/>
+                    </a:solidFill>
                   </a:tcPr>
                 </a:tc>
                 <a:tc>
@@ -14626,14 +14626,14 @@
                     </a:p>
                   </a:txBody>
                   <a:tcPr>
-                    <a:solidFill>
-                      <a:srgbClr val="FFFFFF"/>
-                    </a:solidFill>
                     <a:lnB w="9525" cap="flat">
                       <a:solidFill>
                         <a:srgbClr val="E7E7E5"/>
                       </a:solidFill>
                     </a:lnB>
+                    <a:solidFill>
+                      <a:srgbClr val="FFFFFF"/>
+                    </a:solidFill>
                   </a:tcPr>
                 </a:tc>
               </a:tr>
@@ -14660,14 +14660,14 @@
                     </a:p>
                   </a:txBody>
                   <a:tcPr>
-                    <a:solidFill>
-                      <a:srgbClr val="FFFFFF"/>
-                    </a:solidFill>
                     <a:lnB w="9525" cap="flat">
                       <a:solidFill>
                         <a:srgbClr val="E7E7E5"/>
                       </a:solidFill>
                     </a:lnB>
+                    <a:solidFill>
+                      <a:srgbClr val="FFFFFF"/>
+                    </a:solidFill>
                   </a:tcPr>
                 </a:tc>
                 <a:tc>
@@ -14692,14 +14692,14 @@
                     </a:p>
                   </a:txBody>
                   <a:tcPr>
-                    <a:solidFill>
-                      <a:srgbClr val="FFFFFF"/>
-                    </a:solidFill>
                     <a:lnB w="9525" cap="flat">
                       <a:solidFill>
                         <a:srgbClr val="E7E7E5"/>
                       </a:solidFill>
                     </a:lnB>
+                    <a:solidFill>
+                      <a:srgbClr val="FFFFFF"/>
+                    </a:solidFill>
                   </a:tcPr>
                 </a:tc>
                 <a:tc>
@@ -14724,14 +14724,14 @@
                     </a:p>
                   </a:txBody>
                   <a:tcPr>
-                    <a:solidFill>
-                      <a:srgbClr val="FFFFFF"/>
-                    </a:solidFill>
                     <a:lnB w="9525" cap="flat">
                       <a:solidFill>
                         <a:srgbClr val="E7E7E5"/>
                       </a:solidFill>
                     </a:lnB>
+                    <a:solidFill>
+                      <a:srgbClr val="FFFFFF"/>
+                    </a:solidFill>
                   </a:tcPr>
                 </a:tc>
                 <a:tc>
@@ -14756,14 +14756,14 @@
                     </a:p>
                   </a:txBody>
                   <a:tcPr>
-                    <a:solidFill>
-                      <a:srgbClr val="F2F8F6"/>
-                    </a:solidFill>
                     <a:lnB w="9525" cap="flat">
                       <a:solidFill>
                         <a:srgbClr val="E7E7E5"/>
                       </a:solidFill>
                     </a:lnB>
+                    <a:solidFill>
+                      <a:srgbClr val="F2F8F6"/>
+                    </a:solidFill>
                   </a:tcPr>
                 </a:tc>
                 <a:tc>
@@ -14788,14 +14788,14 @@
                     </a:p>
                   </a:txBody>
                   <a:tcPr>
-                    <a:solidFill>
-                      <a:srgbClr val="FFFFFF"/>
-                    </a:solidFill>
                     <a:lnB w="9525" cap="flat">
                       <a:solidFill>
                         <a:srgbClr val="E7E7E5"/>
                       </a:solidFill>
                     </a:lnB>
+                    <a:solidFill>
+                      <a:srgbClr val="FFFFFF"/>
+                    </a:solidFill>
                   </a:tcPr>
                 </a:tc>
               </a:tr>
@@ -14822,14 +14822,14 @@
                     </a:p>
                   </a:txBody>
                   <a:tcPr>
-                    <a:solidFill>
-                      <a:srgbClr val="FFFFFF"/>
-                    </a:solidFill>
                     <a:lnB w="9525" cap="flat">
                       <a:solidFill>
                         <a:srgbClr val="E7E7E5"/>
                       </a:solidFill>
                     </a:lnB>
+                    <a:solidFill>
+                      <a:srgbClr val="FFFFFF"/>
+                    </a:solidFill>
                   </a:tcPr>
                 </a:tc>
                 <a:tc>
@@ -14854,14 +14854,14 @@
                     </a:p>
                   </a:txBody>
                   <a:tcPr>
-                    <a:solidFill>
-                      <a:srgbClr val="FFFFFF"/>
-                    </a:solidFill>
                     <a:lnB w="9525" cap="flat">
                       <a:solidFill>
                         <a:srgbClr val="E7E7E5"/>
                       </a:solidFill>
                     </a:lnB>
+                    <a:solidFill>
+                      <a:srgbClr val="FFFFFF"/>
+                    </a:solidFill>
                   </a:tcPr>
                 </a:tc>
                 <a:tc>
@@ -14886,14 +14886,14 @@
                     </a:p>
                   </a:txBody>
                   <a:tcPr>
-                    <a:solidFill>
-                      <a:srgbClr val="FFFFFF"/>
-                    </a:solidFill>
                     <a:lnB w="9525" cap="flat">
                       <a:solidFill>
                         <a:srgbClr val="E7E7E5"/>
                       </a:solidFill>
                     </a:lnB>
+                    <a:solidFill>
+                      <a:srgbClr val="FFFFFF"/>
+                    </a:solidFill>
                   </a:tcPr>
                 </a:tc>
                 <a:tc>
@@ -14918,14 +14918,14 @@
                     </a:p>
                   </a:txBody>
                   <a:tcPr>
-                    <a:solidFill>
-                      <a:srgbClr val="F2F8F6"/>
-                    </a:solidFill>
                     <a:lnB w="9525" cap="flat">
                       <a:solidFill>
                         <a:srgbClr val="E7E7E5"/>
                       </a:solidFill>
                     </a:lnB>
+                    <a:solidFill>
+                      <a:srgbClr val="F2F8F6"/>
+                    </a:solidFill>
                   </a:tcPr>
                 </a:tc>
                 <a:tc>
@@ -14950,14 +14950,14 @@
                     </a:p>
                   </a:txBody>
                   <a:tcPr>
-                    <a:solidFill>
-                      <a:srgbClr val="FFFFFF"/>
-                    </a:solidFill>
                     <a:lnB w="9525" cap="flat">
                       <a:solidFill>
                         <a:srgbClr val="E7E7E5"/>
                       </a:solidFill>
                     </a:lnB>
+                    <a:solidFill>
+                      <a:srgbClr val="FFFFFF"/>
+                    </a:solidFill>
                   </a:tcPr>
                 </a:tc>
               </a:tr>
@@ -14984,14 +14984,14 @@
                     </a:p>
                   </a:txBody>
                   <a:tcPr>
-                    <a:solidFill>
-                      <a:srgbClr val="FFFFFF"/>
-                    </a:solidFill>
                     <a:lnB w="9525" cap="flat">
                       <a:solidFill>
                         <a:srgbClr val="E7E7E5"/>
                       </a:solidFill>
                     </a:lnB>
+                    <a:solidFill>
+                      <a:srgbClr val="FFFFFF"/>
+                    </a:solidFill>
                   </a:tcPr>
                 </a:tc>
                 <a:tc>
@@ -15016,14 +15016,14 @@
                     </a:p>
                   </a:txBody>
                   <a:tcPr>
-                    <a:solidFill>
-                      <a:srgbClr val="FFFFFF"/>
-                    </a:solidFill>
                     <a:lnB w="9525" cap="flat">
                       <a:solidFill>
                         <a:srgbClr val="E7E7E5"/>
                       </a:solidFill>
                     </a:lnB>
+                    <a:solidFill>
+                      <a:srgbClr val="FFFFFF"/>
+                    </a:solidFill>
                   </a:tcPr>
                 </a:tc>
                 <a:tc>
@@ -15048,14 +15048,14 @@
                     </a:p>
                   </a:txBody>
                   <a:tcPr>
-                    <a:solidFill>
-                      <a:srgbClr val="FFFFFF"/>
-                    </a:solidFill>
                     <a:lnB w="9525" cap="flat">
                       <a:solidFill>
                         <a:srgbClr val="E7E7E5"/>
                       </a:solidFill>
                     </a:lnB>
+                    <a:solidFill>
+                      <a:srgbClr val="FFFFFF"/>
+                    </a:solidFill>
                   </a:tcPr>
                 </a:tc>
                 <a:tc>
@@ -15080,14 +15080,14 @@
                     </a:p>
                   </a:txBody>
                   <a:tcPr>
-                    <a:solidFill>
-                      <a:srgbClr val="F2F8F6"/>
-                    </a:solidFill>
                     <a:lnB w="9525" cap="flat">
                       <a:solidFill>
                         <a:srgbClr val="E7E7E5"/>
                       </a:solidFill>
                     </a:lnB>
+                    <a:solidFill>
+                      <a:srgbClr val="F2F8F6"/>
+                    </a:solidFill>
                   </a:tcPr>
                 </a:tc>
                 <a:tc>
@@ -15112,14 +15112,14 @@
                     </a:p>
                   </a:txBody>
                   <a:tcPr>
-                    <a:solidFill>
-                      <a:srgbClr val="FFFFFF"/>
-                    </a:solidFill>
                     <a:lnB w="9525" cap="flat">
                       <a:solidFill>
                         <a:srgbClr val="E7E7E5"/>
                       </a:solidFill>
                     </a:lnB>
+                    <a:solidFill>
+                      <a:srgbClr val="FFFFFF"/>
+                    </a:solidFill>
                   </a:tcPr>
                 </a:tc>
               </a:tr>
@@ -15146,14 +15146,14 @@
                     </a:p>
                   </a:txBody>
                   <a:tcPr>
-                    <a:solidFill>
-                      <a:srgbClr val="FFFFFF"/>
-                    </a:solidFill>
                     <a:lnB w="9525" cap="flat">
                       <a:solidFill>
                         <a:srgbClr val="E7E7E5"/>
                       </a:solidFill>
                     </a:lnB>
+                    <a:solidFill>
+                      <a:srgbClr val="FFFFFF"/>
+                    </a:solidFill>
                   </a:tcPr>
                 </a:tc>
                 <a:tc>
@@ -15178,14 +15178,14 @@
                     </a:p>
                   </a:txBody>
                   <a:tcPr>
-                    <a:solidFill>
-                      <a:srgbClr val="FFFFFF"/>
-                    </a:solidFill>
                     <a:lnB w="9525" cap="flat">
                       <a:solidFill>
                         <a:srgbClr val="E7E7E5"/>
                       </a:solidFill>
                     </a:lnB>
+                    <a:solidFill>
+                      <a:srgbClr val="FFFFFF"/>
+                    </a:solidFill>
                   </a:tcPr>
                 </a:tc>
                 <a:tc>
@@ -15210,14 +15210,14 @@
                     </a:p>
                   </a:txBody>
                   <a:tcPr>
-                    <a:solidFill>
-                      <a:srgbClr val="FFFFFF"/>
-                    </a:solidFill>
                     <a:lnB w="9525" cap="flat">
                       <a:solidFill>
                         <a:srgbClr val="E7E7E5"/>
                       </a:solidFill>
                     </a:lnB>
+                    <a:solidFill>
+                      <a:srgbClr val="FFFFFF"/>
+                    </a:solidFill>
                   </a:tcPr>
                 </a:tc>
                 <a:tc>
@@ -15242,14 +15242,14 @@
                     </a:p>
                   </a:txBody>
                   <a:tcPr>
-                    <a:solidFill>
-                      <a:srgbClr val="F2F8F6"/>
-                    </a:solidFill>
                     <a:lnB w="9525" cap="flat">
                       <a:solidFill>
                         <a:srgbClr val="E7E7E5"/>
                       </a:solidFill>
                     </a:lnB>
+                    <a:solidFill>
+                      <a:srgbClr val="F2F8F6"/>
+                    </a:solidFill>
                   </a:tcPr>
                 </a:tc>
                 <a:tc>
@@ -15274,14 +15274,14 @@
                     </a:p>
                   </a:txBody>
                   <a:tcPr>
-                    <a:solidFill>
-                      <a:srgbClr val="FFFFFF"/>
-                    </a:solidFill>
                     <a:lnB w="9525" cap="flat">
                       <a:solidFill>
                         <a:srgbClr val="E7E7E5"/>
                       </a:solidFill>
                     </a:lnB>
+                    <a:solidFill>
+                      <a:srgbClr val="FFFFFF"/>
+                    </a:solidFill>
                   </a:tcPr>
                 </a:tc>
               </a:tr>
@@ -15308,14 +15308,14 @@
                     </a:p>
                   </a:txBody>
                   <a:tcPr>
-                    <a:solidFill>
-                      <a:srgbClr val="FFFFFF"/>
-                    </a:solidFill>
                     <a:lnB w="9525" cap="flat">
                       <a:solidFill>
                         <a:srgbClr val="E7E7E5"/>
                       </a:solidFill>
                     </a:lnB>
+                    <a:solidFill>
+                      <a:srgbClr val="FFFFFF"/>
+                    </a:solidFill>
                   </a:tcPr>
                 </a:tc>
                 <a:tc>
@@ -15340,14 +15340,14 @@
                     </a:p>
                   </a:txBody>
                   <a:tcPr>
-                    <a:solidFill>
-                      <a:srgbClr val="FFFFFF"/>
-                    </a:solidFill>
                     <a:lnB w="9525" cap="flat">
                       <a:solidFill>
                         <a:srgbClr val="E7E7E5"/>
                       </a:solidFill>
                     </a:lnB>
+                    <a:solidFill>
+                      <a:srgbClr val="FFFFFF"/>
+                    </a:solidFill>
                   </a:tcPr>
                 </a:tc>
                 <a:tc>
@@ -15372,14 +15372,14 @@
                     </a:p>
                   </a:txBody>
                   <a:tcPr>
-                    <a:solidFill>
-                      <a:srgbClr val="FFFFFF"/>
-                    </a:solidFill>
                     <a:lnB w="9525" cap="flat">
                       <a:solidFill>
                         <a:srgbClr val="E7E7E5"/>
                       </a:solidFill>
                     </a:lnB>
+                    <a:solidFill>
+                      <a:srgbClr val="FFFFFF"/>
+                    </a:solidFill>
                   </a:tcPr>
                 </a:tc>
                 <a:tc>
@@ -15404,14 +15404,14 @@
                     </a:p>
                   </a:txBody>
                   <a:tcPr>
-                    <a:solidFill>
-                      <a:srgbClr val="F2F8F6"/>
-                    </a:solidFill>
                     <a:lnB w="9525" cap="flat">
                       <a:solidFill>
                         <a:srgbClr val="E7E7E5"/>
                       </a:solidFill>
                     </a:lnB>
+                    <a:solidFill>
+                      <a:srgbClr val="F2F8F6"/>
+                    </a:solidFill>
                   </a:tcPr>
                 </a:tc>
                 <a:tc>
@@ -15436,14 +15436,14 @@
                     </a:p>
                   </a:txBody>
                   <a:tcPr>
-                    <a:solidFill>
-                      <a:srgbClr val="FFFFFF"/>
-                    </a:solidFill>
                     <a:lnB w="9525" cap="flat">
                       <a:solidFill>
                         <a:srgbClr val="E7E7E5"/>
                       </a:solidFill>
                     </a:lnB>
+                    <a:solidFill>
+                      <a:srgbClr val="FFFFFF"/>
+                    </a:solidFill>
                   </a:tcPr>
                 </a:tc>
               </a:tr>
@@ -15470,14 +15470,14 @@
                     </a:p>
                   </a:txBody>
                   <a:tcPr>
-                    <a:solidFill>
-                      <a:srgbClr val="FFFFFF"/>
-                    </a:solidFill>
                     <a:lnB w="9525" cap="flat">
                       <a:solidFill>
                         <a:srgbClr val="E7E7E5"/>
                       </a:solidFill>
                     </a:lnB>
+                    <a:solidFill>
+                      <a:srgbClr val="FFFFFF"/>
+                    </a:solidFill>
                   </a:tcPr>
                 </a:tc>
                 <a:tc>
@@ -15502,14 +15502,14 @@
                     </a:p>
                   </a:txBody>
                   <a:tcPr>
-                    <a:solidFill>
-                      <a:srgbClr val="FFFFFF"/>
-                    </a:solidFill>
                     <a:lnB w="9525" cap="flat">
                       <a:solidFill>
                         <a:srgbClr val="E7E7E5"/>
                       </a:solidFill>
                     </a:lnB>
+                    <a:solidFill>
+                      <a:srgbClr val="FFFFFF"/>
+                    </a:solidFill>
                   </a:tcPr>
                 </a:tc>
                 <a:tc>
@@ -15534,14 +15534,14 @@
                     </a:p>
                   </a:txBody>
                   <a:tcPr>
-                    <a:solidFill>
-                      <a:srgbClr val="FFFFFF"/>
-                    </a:solidFill>
                     <a:lnB w="9525" cap="flat">
                       <a:solidFill>
                         <a:srgbClr val="E7E7E5"/>
                       </a:solidFill>
                     </a:lnB>
+                    <a:solidFill>
+                      <a:srgbClr val="FFFFFF"/>
+                    </a:solidFill>
                   </a:tcPr>
                 </a:tc>
                 <a:tc>
@@ -15566,14 +15566,14 @@
                     </a:p>
                   </a:txBody>
                   <a:tcPr>
-                    <a:solidFill>
-                      <a:srgbClr val="F2F8F6"/>
-                    </a:solidFill>
                     <a:lnB w="9525" cap="flat">
                       <a:solidFill>
                         <a:srgbClr val="E7E7E5"/>
                       </a:solidFill>
                     </a:lnB>
+                    <a:solidFill>
+                      <a:srgbClr val="F2F8F6"/>
+                    </a:solidFill>
                   </a:tcPr>
                 </a:tc>
                 <a:tc>
@@ -15598,14 +15598,14 @@
                     </a:p>
                   </a:txBody>
                   <a:tcPr>
-                    <a:solidFill>
-                      <a:srgbClr val="FFFFFF"/>
-                    </a:solidFill>
                     <a:lnB w="9525" cap="flat">
                       <a:solidFill>
                         <a:srgbClr val="E7E7E5"/>
                       </a:solidFill>
                     </a:lnB>
+                    <a:solidFill>
+                      <a:srgbClr val="FFFFFF"/>
+                    </a:solidFill>
                   </a:tcPr>
                 </a:tc>
               </a:tr>
@@ -15632,14 +15632,14 @@
                     </a:p>
                   </a:txBody>
                   <a:tcPr>
-                    <a:solidFill>
-                      <a:srgbClr val="FFFFFF"/>
-                    </a:solidFill>
                     <a:lnB w="9525" cap="flat">
                       <a:solidFill>
                         <a:srgbClr val="E7E7E5"/>
                       </a:solidFill>
                     </a:lnB>
+                    <a:solidFill>
+                      <a:srgbClr val="FFFFFF"/>
+                    </a:solidFill>
                   </a:tcPr>
                 </a:tc>
                 <a:tc>
@@ -15664,14 +15664,14 @@
                     </a:p>
                   </a:txBody>
                   <a:tcPr>
-                    <a:solidFill>
-                      <a:srgbClr val="FFFFFF"/>
-                    </a:solidFill>
                     <a:lnB w="9525" cap="flat">
                       <a:solidFill>
                         <a:srgbClr val="E7E7E5"/>
                       </a:solidFill>
                     </a:lnB>
+                    <a:solidFill>
+                      <a:srgbClr val="FFFFFF"/>
+                    </a:solidFill>
                   </a:tcPr>
                 </a:tc>
                 <a:tc>
@@ -15696,14 +15696,14 @@
                     </a:p>
                   </a:txBody>
                   <a:tcPr>
-                    <a:solidFill>
-                      <a:srgbClr val="FFFFFF"/>
-                    </a:solidFill>
                     <a:lnB w="9525" cap="flat">
                       <a:solidFill>
                         <a:srgbClr val="E7E7E5"/>
                       </a:solidFill>
                     </a:lnB>
+                    <a:solidFill>
+                      <a:srgbClr val="FFFFFF"/>
+                    </a:solidFill>
                   </a:tcPr>
                 </a:tc>
                 <a:tc>
@@ -15728,14 +15728,14 @@
                     </a:p>
                   </a:txBody>
                   <a:tcPr>
-                    <a:solidFill>
-                      <a:srgbClr val="F2F8F6"/>
-                    </a:solidFill>
                     <a:lnB w="9525" cap="flat">
                       <a:solidFill>
                         <a:srgbClr val="E7E7E5"/>
                       </a:solidFill>
                     </a:lnB>
+                    <a:solidFill>
+                      <a:srgbClr val="F2F8F6"/>
+                    </a:solidFill>
                   </a:tcPr>
                 </a:tc>
                 <a:tc>
@@ -15760,14 +15760,14 @@
                     </a:p>
                   </a:txBody>
                   <a:tcPr>
-                    <a:solidFill>
-                      <a:srgbClr val="FFFFFF"/>
-                    </a:solidFill>
                     <a:lnB w="9525" cap="flat">
                       <a:solidFill>
                         <a:srgbClr val="E7E7E5"/>
                       </a:solidFill>
                     </a:lnB>
+                    <a:solidFill>
+                      <a:srgbClr val="FFFFFF"/>
+                    </a:solidFill>
                   </a:tcPr>
                 </a:tc>
               </a:tr>
@@ -15794,14 +15794,14 @@
                     </a:p>
                   </a:txBody>
                   <a:tcPr>
-                    <a:solidFill>
-                      <a:srgbClr val="FFFFFF"/>
-                    </a:solidFill>
                     <a:lnB w="9525" cap="flat">
                       <a:solidFill>
                         <a:srgbClr val="E7E7E5"/>
                       </a:solidFill>
                     </a:lnB>
+                    <a:solidFill>
+                      <a:srgbClr val="FFFFFF"/>
+                    </a:solidFill>
                   </a:tcPr>
                 </a:tc>
                 <a:tc>
@@ -15826,14 +15826,14 @@
                     </a:p>
                   </a:txBody>
                   <a:tcPr>
-                    <a:solidFill>
-                      <a:srgbClr val="FFFFFF"/>
-                    </a:solidFill>
                     <a:lnB w="9525" cap="flat">
                       <a:solidFill>
                         <a:srgbClr val="E7E7E5"/>
                       </a:solidFill>
                     </a:lnB>
+                    <a:solidFill>
+                      <a:srgbClr val="FFFFFF"/>
+                    </a:solidFill>
                   </a:tcPr>
                 </a:tc>
                 <a:tc>
@@ -15858,14 +15858,14 @@
                     </a:p>
                   </a:txBody>
                   <a:tcPr>
-                    <a:solidFill>
-                      <a:srgbClr val="FFFFFF"/>
-                    </a:solidFill>
                     <a:lnB w="9525" cap="flat">
                       <a:solidFill>
                         <a:srgbClr val="E7E7E5"/>
                       </a:solidFill>
                     </a:lnB>
+                    <a:solidFill>
+                      <a:srgbClr val="FFFFFF"/>
+                    </a:solidFill>
                   </a:tcPr>
                 </a:tc>
                 <a:tc>
@@ -15890,14 +15890,14 @@
                     </a:p>
                   </a:txBody>
                   <a:tcPr>
-                    <a:solidFill>
-                      <a:srgbClr val="F2F8F6"/>
-                    </a:solidFill>
                     <a:lnB w="9525" cap="flat">
                       <a:solidFill>
                         <a:srgbClr val="E7E7E5"/>
                       </a:solidFill>
                     </a:lnB>
+                    <a:solidFill>
+                      <a:srgbClr val="F2F8F6"/>
+                    </a:solidFill>
                   </a:tcPr>
                 </a:tc>
                 <a:tc>
@@ -15922,14 +15922,14 @@
                     </a:p>
                   </a:txBody>
                   <a:tcPr>
-                    <a:solidFill>
-                      <a:srgbClr val="FFFFFF"/>
-                    </a:solidFill>
                     <a:lnB w="9525" cap="flat">
                       <a:solidFill>
                         <a:srgbClr val="E7E7E5"/>
                       </a:solidFill>
                     </a:lnB>
+                    <a:solidFill>
+                      <a:srgbClr val="FFFFFF"/>
+                    </a:solidFill>
                   </a:tcPr>
                 </a:tc>
               </a:tr>
@@ -15956,14 +15956,14 @@
                     </a:p>
                   </a:txBody>
                   <a:tcPr>
-                    <a:solidFill>
-                      <a:srgbClr val="FFFFFF"/>
-                    </a:solidFill>
                     <a:lnB w="9525" cap="flat">
                       <a:solidFill>
                         <a:srgbClr val="E7E7E5"/>
                       </a:solidFill>
                     </a:lnB>
+                    <a:solidFill>
+                      <a:srgbClr val="FFFFFF"/>
+                    </a:solidFill>
                   </a:tcPr>
                 </a:tc>
                 <a:tc>
@@ -15988,14 +15988,14 @@
                     </a:p>
                   </a:txBody>
                   <a:tcPr>
-                    <a:solidFill>
-                      <a:srgbClr val="FFFFFF"/>
-                    </a:solidFill>
                     <a:lnB w="9525" cap="flat">
                       <a:solidFill>
                         <a:srgbClr val="E7E7E5"/>
                       </a:solidFill>
                     </a:lnB>
+                    <a:solidFill>
+                      <a:srgbClr val="FFFFFF"/>
+                    </a:solidFill>
                   </a:tcPr>
                 </a:tc>
                 <a:tc>
@@ -16020,14 +16020,14 @@
                     </a:p>
                   </a:txBody>
                   <a:tcPr>
-                    <a:solidFill>
-                      <a:srgbClr val="FFFFFF"/>
-                    </a:solidFill>
                     <a:lnB w="9525" cap="flat">
                       <a:solidFill>
                         <a:srgbClr val="E7E7E5"/>
                       </a:solidFill>
                     </a:lnB>
+                    <a:solidFill>
+                      <a:srgbClr val="FFFFFF"/>
+                    </a:solidFill>
                   </a:tcPr>
                 </a:tc>
                 <a:tc>
@@ -16052,14 +16052,14 @@
                     </a:p>
                   </a:txBody>
                   <a:tcPr>
-                    <a:solidFill>
-                      <a:srgbClr val="F2F8F6"/>
-                    </a:solidFill>
                     <a:lnB w="9525" cap="flat">
                       <a:solidFill>
                         <a:srgbClr val="E7E7E5"/>
                       </a:solidFill>
                     </a:lnB>
+                    <a:solidFill>
+                      <a:srgbClr val="F2F8F6"/>
+                    </a:solidFill>
                   </a:tcPr>
                 </a:tc>
                 <a:tc>
@@ -16084,14 +16084,14 @@
                     </a:p>
                   </a:txBody>
                   <a:tcPr>
-                    <a:solidFill>
-                      <a:srgbClr val="FFFFFF"/>
-                    </a:solidFill>
                     <a:lnB w="9525" cap="flat">
                       <a:solidFill>
                         <a:srgbClr val="E7E7E5"/>
                       </a:solidFill>
                     </a:lnB>
+                    <a:solidFill>
+                      <a:srgbClr val="FFFFFF"/>
+                    </a:solidFill>
                   </a:tcPr>
                 </a:tc>
               </a:tr>
@@ -16118,14 +16118,14 @@
                     </a:p>
                   </a:txBody>
                   <a:tcPr>
-                    <a:solidFill>
-                      <a:srgbClr val="FFFFFF"/>
-                    </a:solidFill>
                     <a:lnB w="9525" cap="flat">
                       <a:solidFill>
                         <a:srgbClr val="E7E7E5"/>
                       </a:solidFill>
                     </a:lnB>
+                    <a:solidFill>
+                      <a:srgbClr val="FFFFFF"/>
+                    </a:solidFill>
                   </a:tcPr>
                 </a:tc>
                 <a:tc>
@@ -16150,14 +16150,14 @@
                     </a:p>
                   </a:txBody>
                   <a:tcPr>
-                    <a:solidFill>
-                      <a:srgbClr val="FFFFFF"/>
-                    </a:solidFill>
                     <a:lnB w="9525" cap="flat">
                       <a:solidFill>
                         <a:srgbClr val="E7E7E5"/>
                       </a:solidFill>
                     </a:lnB>
+                    <a:solidFill>
+                      <a:srgbClr val="FFFFFF"/>
+                    </a:solidFill>
                   </a:tcPr>
                 </a:tc>
                 <a:tc>
@@ -16182,14 +16182,14 @@
                     </a:p>
                   </a:txBody>
                   <a:tcPr>
-                    <a:solidFill>
-                      <a:srgbClr val="FFFFFF"/>
-                    </a:solidFill>
                     <a:lnB w="9525" cap="flat">
                       <a:solidFill>
                         <a:srgbClr val="E7E7E5"/>
                       </a:solidFill>
                     </a:lnB>
+                    <a:solidFill>
+                      <a:srgbClr val="FFFFFF"/>
+                    </a:solidFill>
                   </a:tcPr>
                 </a:tc>
                 <a:tc>
@@ -16214,14 +16214,14 @@
                     </a:p>
                   </a:txBody>
                   <a:tcPr>
-                    <a:solidFill>
-                      <a:srgbClr val="F2F8F6"/>
-                    </a:solidFill>
                     <a:lnB w="9525" cap="flat">
                       <a:solidFill>
                         <a:srgbClr val="E7E7E5"/>
                       </a:solidFill>
                     </a:lnB>
+                    <a:solidFill>
+                      <a:srgbClr val="F2F8F6"/>
+                    </a:solidFill>
                   </a:tcPr>
                 </a:tc>
                 <a:tc>
@@ -16246,14 +16246,14 @@
                     </a:p>
                   </a:txBody>
                   <a:tcPr>
-                    <a:solidFill>
-                      <a:srgbClr val="FFFFFF"/>
-                    </a:solidFill>
                     <a:lnB w="9525" cap="flat">
                       <a:solidFill>
                         <a:srgbClr val="E7E7E5"/>
                       </a:solidFill>
                     </a:lnB>
+                    <a:solidFill>
+                      <a:srgbClr val="FFFFFF"/>
+                    </a:solidFill>
                   </a:tcPr>
                 </a:tc>
               </a:tr>
@@ -25917,14 +25917,14 @@
                     </a:p>
                   </a:txBody>
                   <a:tcPr>
-                    <a:solidFill>
-                      <a:srgbClr val="FFFFFF"/>
-                    </a:solidFill>
                     <a:lnB w="9525" cap="flat">
                       <a:solidFill>
                         <a:srgbClr val="E7E7E5"/>
                       </a:solidFill>
                     </a:lnB>
+                    <a:solidFill>
+                      <a:srgbClr val="FFFFFF"/>
+                    </a:solidFill>
                   </a:tcPr>
                 </a:tc>
                 <a:tc>
@@ -25955,14 +25955,14 @@
                     </a:p>
                   </a:txBody>
                   <a:tcPr>
-                    <a:solidFill>
-                      <a:srgbClr val="FFFFFF"/>
-                    </a:solidFill>
                     <a:lnB w="9525" cap="flat">
                       <a:solidFill>
                         <a:srgbClr val="E7E7E5"/>
                       </a:solidFill>
                     </a:lnB>
+                    <a:solidFill>
+                      <a:srgbClr val="FFFFFF"/>
+                    </a:solidFill>
                   </a:tcPr>
                 </a:tc>
                 <a:tc>
@@ -25993,14 +25993,14 @@
                     </a:p>
                   </a:txBody>
                   <a:tcPr>
-                    <a:solidFill>
-                      <a:srgbClr val="FFFFFF"/>
-                    </a:solidFill>
                     <a:lnB w="9525" cap="flat">
                       <a:solidFill>
                         <a:srgbClr val="E7E7E5"/>
                       </a:solidFill>
                     </a:lnB>
+                    <a:solidFill>
+                      <a:srgbClr val="FFFFFF"/>
+                    </a:solidFill>
                   </a:tcPr>
                 </a:tc>
               </a:tr>
@@ -26027,14 +26027,14 @@
                     </a:p>
                   </a:txBody>
                   <a:tcPr>
-                    <a:solidFill>
-                      <a:srgbClr val="FFFFFF"/>
-                    </a:solidFill>
                     <a:lnB w="9525" cap="flat">
                       <a:solidFill>
                         <a:srgbClr val="E7E7E5"/>
                       </a:solidFill>
                     </a:lnB>
+                    <a:solidFill>
+                      <a:srgbClr val="FFFFFF"/>
+                    </a:solidFill>
                   </a:tcPr>
                 </a:tc>
                 <a:tc>
@@ -26075,14 +26075,14 @@
                     </a:p>
                   </a:txBody>
                   <a:tcPr>
-                    <a:solidFill>
-                      <a:srgbClr val="F2F8F6"/>
-                    </a:solidFill>
                     <a:lnB w="9525" cap="flat">
                       <a:solidFill>
                         <a:srgbClr val="E7E7E5"/>
                       </a:solidFill>
                     </a:lnB>
+                    <a:solidFill>
+                      <a:srgbClr val="F2F8F6"/>
+                    </a:solidFill>
                   </a:tcPr>
                 </a:tc>
                 <a:tc>
@@ -26107,14 +26107,14 @@
                     </a:p>
                   </a:txBody>
                   <a:tcPr>
-                    <a:solidFill>
-                      <a:srgbClr val="FFFFFF"/>
-                    </a:solidFill>
                     <a:lnB w="9525" cap="flat">
                       <a:solidFill>
                         <a:srgbClr val="E7E7E5"/>
                       </a:solidFill>
                     </a:lnB>
+                    <a:solidFill>
+                      <a:srgbClr val="FFFFFF"/>
+                    </a:solidFill>
                   </a:tcPr>
                 </a:tc>
               </a:tr>
@@ -26141,14 +26141,14 @@
                     </a:p>
                   </a:txBody>
                   <a:tcPr>
-                    <a:solidFill>
-                      <a:srgbClr val="FFFFFF"/>
-                    </a:solidFill>
                     <a:lnB w="9525" cap="flat">
                       <a:solidFill>
                         <a:srgbClr val="E7E7E5"/>
                       </a:solidFill>
                     </a:lnB>
+                    <a:solidFill>
+                      <a:srgbClr val="FFFFFF"/>
+                    </a:solidFill>
                   </a:tcPr>
                 </a:tc>
                 <a:tc>
@@ -26173,14 +26173,14 @@
                     </a:p>
                   </a:txBody>
                   <a:tcPr>
-                    <a:solidFill>
-                      <a:srgbClr val="F2F8F6"/>
-                    </a:solidFill>
                     <a:lnB w="9525" cap="flat">
                       <a:solidFill>
                         <a:srgbClr val="E7E7E5"/>
                       </a:solidFill>
                     </a:lnB>
+                    <a:solidFill>
+                      <a:srgbClr val="F2F8F6"/>
+                    </a:solidFill>
                   </a:tcPr>
                 </a:tc>
                 <a:tc>
@@ -26205,14 +26205,14 @@
                     </a:p>
                   </a:txBody>
                   <a:tcPr>
-                    <a:solidFill>
-                      <a:srgbClr val="FFFFFF"/>
-                    </a:solidFill>
                     <a:lnB w="9525" cap="flat">
                       <a:solidFill>
                         <a:srgbClr val="E7E7E5"/>
                       </a:solidFill>
                     </a:lnB>
+                    <a:solidFill>
+                      <a:srgbClr val="FFFFFF"/>
+                    </a:solidFill>
                   </a:tcPr>
                 </a:tc>
               </a:tr>
@@ -26239,14 +26239,14 @@
                     </a:p>
                   </a:txBody>
                   <a:tcPr>
-                    <a:solidFill>
-                      <a:srgbClr val="FFFFFF"/>
-                    </a:solidFill>
                     <a:lnB w="9525" cap="flat">
                       <a:solidFill>
                         <a:srgbClr val="E7E7E5"/>
                       </a:solidFill>
                     </a:lnB>
+                    <a:solidFill>
+                      <a:srgbClr val="FFFFFF"/>
+                    </a:solidFill>
                   </a:tcPr>
                 </a:tc>
                 <a:tc>
@@ -26271,14 +26271,14 @@
                     </a:p>
                   </a:txBody>
                   <a:tcPr>
-                    <a:solidFill>
-                      <a:srgbClr val="F2F8F6"/>
-                    </a:solidFill>
                     <a:lnB w="9525" cap="flat">
                       <a:solidFill>
                         <a:srgbClr val="E7E7E5"/>
                       </a:solidFill>
                     </a:lnB>
+                    <a:solidFill>
+                      <a:srgbClr val="F2F8F6"/>
+                    </a:solidFill>
                   </a:tcPr>
                 </a:tc>
                 <a:tc>
@@ -26303,14 +26303,14 @@
                     </a:p>
                   </a:txBody>
                   <a:tcPr>
-                    <a:solidFill>
-                      <a:srgbClr val="FFFFFF"/>
-                    </a:solidFill>
                     <a:lnB w="9525" cap="flat">
                       <a:solidFill>
                         <a:srgbClr val="E7E7E5"/>
                       </a:solidFill>
                     </a:lnB>
+                    <a:solidFill>
+                      <a:srgbClr val="FFFFFF"/>
+                    </a:solidFill>
                   </a:tcPr>
                 </a:tc>
               </a:tr>
@@ -26337,14 +26337,14 @@
                     </a:p>
                   </a:txBody>
                   <a:tcPr>
-                    <a:solidFill>
-                      <a:srgbClr val="FFFFFF"/>
-                    </a:solidFill>
                     <a:lnB w="9525" cap="flat">
                       <a:solidFill>
                         <a:srgbClr val="E7E7E5"/>
                       </a:solidFill>
                     </a:lnB>
+                    <a:solidFill>
+                      <a:srgbClr val="FFFFFF"/>
+                    </a:solidFill>
                   </a:tcPr>
                 </a:tc>
                 <a:tc>
@@ -26369,14 +26369,14 @@
                     </a:p>
                   </a:txBody>
                   <a:tcPr>
-                    <a:solidFill>
-                      <a:srgbClr val="F2F8F6"/>
-                    </a:solidFill>
                     <a:lnB w="9525" cap="flat">
                       <a:solidFill>
                         <a:srgbClr val="E7E7E5"/>
                       </a:solidFill>
                     </a:lnB>
+                    <a:solidFill>
+                      <a:srgbClr val="F2F8F6"/>
+                    </a:solidFill>
                   </a:tcPr>
                 </a:tc>
                 <a:tc>
@@ -26401,14 +26401,14 @@
                     </a:p>
                   </a:txBody>
                   <a:tcPr>
-                    <a:solidFill>
-                      <a:srgbClr val="FFFFFF"/>
-                    </a:solidFill>
                     <a:lnB w="9525" cap="flat">
                       <a:solidFill>
                         <a:srgbClr val="E7E7E5"/>
                       </a:solidFill>
                     </a:lnB>
+                    <a:solidFill>
+                      <a:srgbClr val="FFFFFF"/>
+                    </a:solidFill>
                   </a:tcPr>
                 </a:tc>
               </a:tr>
@@ -26435,14 +26435,14 @@
                     </a:p>
                   </a:txBody>
                   <a:tcPr>
-                    <a:solidFill>
-                      <a:srgbClr val="FFFFFF"/>
-                    </a:solidFill>
                     <a:lnB w="9525" cap="flat">
                       <a:solidFill>
                         <a:srgbClr val="E7E7E5"/>
                       </a:solidFill>
                     </a:lnB>
+                    <a:solidFill>
+                      <a:srgbClr val="FFFFFF"/>
+                    </a:solidFill>
                   </a:tcPr>
                 </a:tc>
                 <a:tc>
@@ -26467,14 +26467,14 @@
                     </a:p>
                   </a:txBody>
                   <a:tcPr>
-                    <a:solidFill>
-                      <a:srgbClr val="F2F8F6"/>
-                    </a:solidFill>
                     <a:lnB w="9525" cap="flat">
                       <a:solidFill>
                         <a:srgbClr val="E7E7E5"/>
                       </a:solidFill>
                     </a:lnB>
+                    <a:solidFill>
+                      <a:srgbClr val="F2F8F6"/>
+                    </a:solidFill>
                   </a:tcPr>
                 </a:tc>
                 <a:tc>
@@ -26499,14 +26499,14 @@
                     </a:p>
                   </a:txBody>
                   <a:tcPr>
-                    <a:solidFill>
-                      <a:srgbClr val="FFFFFF"/>
-                    </a:solidFill>
                     <a:lnB w="9525" cap="flat">
                       <a:solidFill>
                         <a:srgbClr val="E7E7E5"/>
                       </a:solidFill>
                     </a:lnB>
+                    <a:solidFill>
+                      <a:srgbClr val="FFFFFF"/>
+                    </a:solidFill>
                   </a:tcPr>
                 </a:tc>
               </a:tr>
@@ -26533,14 +26533,14 @@
                     </a:p>
                   </a:txBody>
                   <a:tcPr>
-                    <a:solidFill>
-                      <a:srgbClr val="FFFFFF"/>
-                    </a:solidFill>
                     <a:lnB w="9525" cap="flat">
                       <a:solidFill>
                         <a:srgbClr val="E7E7E5"/>
                       </a:solidFill>
                     </a:lnB>
+                    <a:solidFill>
+                      <a:srgbClr val="FFFFFF"/>
+                    </a:solidFill>
                   </a:tcPr>
                 </a:tc>
                 <a:tc>
@@ -26565,14 +26565,14 @@
                     </a:p>
                   </a:txBody>
                   <a:tcPr>
-                    <a:solidFill>
-                      <a:srgbClr val="F2F8F6"/>
-                    </a:solidFill>
                     <a:lnB w="9525" cap="flat">
                       <a:solidFill>
                         <a:srgbClr val="E7E7E5"/>
                       </a:solidFill>
                     </a:lnB>
+                    <a:solidFill>
+                      <a:srgbClr val="F2F8F6"/>
+                    </a:solidFill>
                   </a:tcPr>
                 </a:tc>
                 <a:tc>
@@ -26597,14 +26597,14 @@
                     </a:p>
                   </a:txBody>
                   <a:tcPr>
-                    <a:solidFill>
-                      <a:srgbClr val="FFFFFF"/>
-                    </a:solidFill>
                     <a:lnB w="9525" cap="flat">
                       <a:solidFill>
                         <a:srgbClr val="E7E7E5"/>
                       </a:solidFill>
                     </a:lnB>
+                    <a:solidFill>
+                      <a:srgbClr val="FFFFFF"/>
+                    </a:solidFill>
                   </a:tcPr>
                 </a:tc>
               </a:tr>
@@ -26829,14 +26829,14 @@
                     </a:p>
                   </a:txBody>
                   <a:tcPr>
-                    <a:solidFill>
-                      <a:srgbClr val="FFFFFF"/>
-                    </a:solidFill>
                     <a:lnB w="9525" cap="flat">
                       <a:solidFill>
                         <a:srgbClr val="E7E7E5"/>
                       </a:solidFill>
                     </a:lnB>
+                    <a:solidFill>
+                      <a:srgbClr val="FFFFFF"/>
+                    </a:solidFill>
                   </a:tcPr>
                 </a:tc>
                 <a:tc>
@@ -26856,14 +26856,14 @@
                     </a:p>
                   </a:txBody>
                   <a:tcPr>
-                    <a:solidFill>
-                      <a:srgbClr val="FFFFFF"/>
-                    </a:solidFill>
                     <a:lnB w="9525" cap="flat">
                       <a:solidFill>
                         <a:srgbClr val="E7E7E5"/>
                       </a:solidFill>
                     </a:lnB>
+                    <a:solidFill>
+                      <a:srgbClr val="FFFFFF"/>
+                    </a:solidFill>
                   </a:tcPr>
                 </a:tc>
                 <a:tc>
@@ -26883,14 +26883,14 @@
                     </a:p>
                   </a:txBody>
                   <a:tcPr>
-                    <a:solidFill>
-                      <a:srgbClr val="FFFFFF"/>
-                    </a:solidFill>
                     <a:lnB w="9525" cap="flat">
                       <a:solidFill>
                         <a:srgbClr val="E7E7E5"/>
                       </a:solidFill>
                     </a:lnB>
+                    <a:solidFill>
+                      <a:srgbClr val="FFFFFF"/>
+                    </a:solidFill>
                   </a:tcPr>
                 </a:tc>
                 <a:tc>
@@ -26910,14 +26910,14 @@
                     </a:p>
                   </a:txBody>
                   <a:tcPr>
-                    <a:solidFill>
-                      <a:srgbClr val="FFFFFF"/>
-                    </a:solidFill>
                     <a:lnB w="9525" cap="flat">
                       <a:solidFill>
                         <a:srgbClr val="E7E7E5"/>
                       </a:solidFill>
                     </a:lnB>
+                    <a:solidFill>
+                      <a:srgbClr val="FFFFFF"/>
+                    </a:solidFill>
                   </a:tcPr>
                 </a:tc>
               </a:tr>
@@ -26944,14 +26944,14 @@
                     </a:p>
                   </a:txBody>
                   <a:tcPr>
-                    <a:solidFill>
-                      <a:srgbClr val="FFFFFF"/>
-                    </a:solidFill>
                     <a:lnB w="9525" cap="flat">
                       <a:solidFill>
                         <a:srgbClr val="E7E7E5"/>
                       </a:solidFill>
                     </a:lnB>
+                    <a:solidFill>
+                      <a:srgbClr val="FFFFFF"/>
+                    </a:solidFill>
                   </a:tcPr>
                 </a:tc>
                 <a:tc>
@@ -26976,14 +26976,14 @@
                     </a:p>
                   </a:txBody>
                   <a:tcPr>
-                    <a:solidFill>
-                      <a:srgbClr val="FFFFFF"/>
-                    </a:solidFill>
                     <a:lnB w="9525" cap="flat">
                       <a:solidFill>
                         <a:srgbClr val="E7E7E5"/>
                       </a:solidFill>
                     </a:lnB>
+                    <a:solidFill>
+                      <a:srgbClr val="FFFFFF"/>
+                    </a:solidFill>
                   </a:tcPr>
                 </a:tc>
                 <a:tc>
@@ -27008,14 +27008,14 @@
                     </a:p>
                   </a:txBody>
                   <a:tcPr>
-                    <a:solidFill>
-                      <a:srgbClr val="FFFFFF"/>
-                    </a:solidFill>
                     <a:lnB w="9525" cap="flat">
                       <a:solidFill>
                         <a:srgbClr val="E7E7E5"/>
                       </a:solidFill>
                     </a:lnB>
+                    <a:solidFill>
+                      <a:srgbClr val="FFFFFF"/>
+                    </a:solidFill>
                   </a:tcPr>
                 </a:tc>
                 <a:tc>
@@ -27040,14 +27040,14 @@
                     </a:p>
                   </a:txBody>
                   <a:tcPr>
-                    <a:solidFill>
-                      <a:srgbClr val="FFFFFF"/>
-                    </a:solidFill>
                     <a:lnB w="9525" cap="flat">
                       <a:solidFill>
                         <a:srgbClr val="E7E7E5"/>
                       </a:solidFill>
                     </a:lnB>
+                    <a:solidFill>
+                      <a:srgbClr val="FFFFFF"/>
+                    </a:solidFill>
                   </a:tcPr>
                 </a:tc>
               </a:tr>
@@ -27074,14 +27074,14 @@
                     </a:p>
                   </a:txBody>
                   <a:tcPr>
-                    <a:solidFill>
-                      <a:srgbClr val="FFFFFF"/>
-                    </a:solidFill>
                     <a:lnB w="9525" cap="flat">
                       <a:solidFill>
                         <a:srgbClr val="E7E7E5"/>
                       </a:solidFill>
                     </a:lnB>
+                    <a:solidFill>
+                      <a:srgbClr val="FFFFFF"/>
+                    </a:solidFill>
                   </a:tcPr>
                 </a:tc>
                 <a:tc>
@@ -27106,14 +27106,14 @@
                     </a:p>
                   </a:txBody>
                   <a:tcPr>
-                    <a:solidFill>
-                      <a:srgbClr val="FFFFFF"/>
-                    </a:solidFill>
                     <a:lnB w="9525" cap="flat">
                       <a:solidFill>
                         <a:srgbClr val="E7E7E5"/>
                       </a:solidFill>
                     </a:lnB>
+                    <a:solidFill>
+                      <a:srgbClr val="FFFFFF"/>
+                    </a:solidFill>
                   </a:tcPr>
                 </a:tc>
                 <a:tc>
@@ -27138,14 +27138,14 @@
                     </a:p>
                   </a:txBody>
                   <a:tcPr>
-                    <a:solidFill>
-                      <a:srgbClr val="FFFFFF"/>
-                    </a:solidFill>
                     <a:lnB w="9525" cap="flat">
                       <a:solidFill>
                         <a:srgbClr val="E7E7E5"/>
                       </a:solidFill>
                     </a:lnB>
+                    <a:solidFill>
+                      <a:srgbClr val="FFFFFF"/>
+                    </a:solidFill>
                   </a:tcPr>
                 </a:tc>
                 <a:tc>
@@ -27170,14 +27170,14 @@
                     </a:p>
                   </a:txBody>
                   <a:tcPr>
-                    <a:solidFill>
-                      <a:srgbClr val="FFFFFF"/>
-                    </a:solidFill>
                     <a:lnB w="9525" cap="flat">
                       <a:solidFill>
                         <a:srgbClr val="E7E7E5"/>
                       </a:solidFill>
                     </a:lnB>
+                    <a:solidFill>
+                      <a:srgbClr val="FFFFFF"/>
+                    </a:solidFill>
                   </a:tcPr>
                 </a:tc>
               </a:tr>
@@ -27204,14 +27204,14 @@
                     </a:p>
                   </a:txBody>
                   <a:tcPr>
-                    <a:solidFill>
-                      <a:srgbClr val="FFFFFF"/>
-                    </a:solidFill>
                     <a:lnB w="9525" cap="flat">
                       <a:solidFill>
                         <a:srgbClr val="E7E7E5"/>
                       </a:solidFill>
                     </a:lnB>
+                    <a:solidFill>
+                      <a:srgbClr val="FFFFFF"/>
+                    </a:solidFill>
                   </a:tcPr>
                 </a:tc>
                 <a:tc>
@@ -27236,14 +27236,14 @@
                     </a:p>
                   </a:txBody>
                   <a:tcPr>
-                    <a:solidFill>
-                      <a:srgbClr val="FFFFFF"/>
-                    </a:solidFill>
                     <a:lnB w="9525" cap="flat">
                       <a:solidFill>
                         <a:srgbClr val="E7E7E5"/>
                       </a:solidFill>
                     </a:lnB>
+                    <a:solidFill>
+                      <a:srgbClr val="FFFFFF"/>
+                    </a:solidFill>
                   </a:tcPr>
                 </a:tc>
                 <a:tc>
@@ -27268,14 +27268,14 @@
                     </a:p>
                   </a:txBody>
                   <a:tcPr>
-                    <a:solidFill>
-                      <a:srgbClr val="FFFFFF"/>
-                    </a:solidFill>
                     <a:lnB w="9525" cap="flat">
                       <a:solidFill>
                         <a:srgbClr val="E7E7E5"/>
                       </a:solidFill>
                     </a:lnB>
+                    <a:solidFill>
+                      <a:srgbClr val="FFFFFF"/>
+                    </a:solidFill>
                   </a:tcPr>
                 </a:tc>
                 <a:tc>
@@ -27300,14 +27300,14 @@
                     </a:p>
                   </a:txBody>
                   <a:tcPr>
-                    <a:solidFill>
-                      <a:srgbClr val="FFFFFF"/>
-                    </a:solidFill>
                     <a:lnB w="9525" cap="flat">
                       <a:solidFill>
                         <a:srgbClr val="E7E7E5"/>
                       </a:solidFill>
                     </a:lnB>
+                    <a:solidFill>
+                      <a:srgbClr val="FFFFFF"/>
+                    </a:solidFill>
                   </a:tcPr>
                 </a:tc>
               </a:tr>
@@ -27334,14 +27334,14 @@
                     </a:p>
                   </a:txBody>
                   <a:tcPr>
-                    <a:solidFill>
-                      <a:srgbClr val="FFFFFF"/>
-                    </a:solidFill>
                     <a:lnB w="9525" cap="flat">
                       <a:solidFill>
                         <a:srgbClr val="E7E7E5"/>
                       </a:solidFill>
                     </a:lnB>
+                    <a:solidFill>
+                      <a:srgbClr val="FFFFFF"/>
+                    </a:solidFill>
                   </a:tcPr>
                 </a:tc>
                 <a:tc>
@@ -27366,14 +27366,14 @@
                     </a:p>
                   </a:txBody>
                   <a:tcPr>
-                    <a:solidFill>
-                      <a:srgbClr val="FFFFFF"/>
-                    </a:solidFill>
                     <a:lnB w="9525" cap="flat">
                       <a:solidFill>
                         <a:srgbClr val="E7E7E5"/>
                       </a:solidFill>
                     </a:lnB>
+                    <a:solidFill>
+                      <a:srgbClr val="FFFFFF"/>
+                    </a:solidFill>
                   </a:tcPr>
                 </a:tc>
                 <a:tc>
@@ -27398,14 +27398,14 @@
                     </a:p>
                   </a:txBody>
                   <a:tcPr>
-                    <a:solidFill>
-                      <a:srgbClr val="FFFFFF"/>
-                    </a:solidFill>
                     <a:lnB w="9525" cap="flat">
                       <a:solidFill>
                         <a:srgbClr val="E7E7E5"/>
                       </a:solidFill>
                     </a:lnB>
+                    <a:solidFill>
+                      <a:srgbClr val="FFFFFF"/>
+                    </a:solidFill>
                   </a:tcPr>
                 </a:tc>
                 <a:tc>
@@ -27430,14 +27430,14 @@
                     </a:p>
                   </a:txBody>
                   <a:tcPr>
-                    <a:solidFill>
-                      <a:srgbClr val="FFFFFF"/>
-                    </a:solidFill>
                     <a:lnB w="9525" cap="flat">
                       <a:solidFill>
                         <a:srgbClr val="E7E7E5"/>
                       </a:solidFill>
                     </a:lnB>
+                    <a:solidFill>
+                      <a:srgbClr val="FFFFFF"/>
+                    </a:solidFill>
                   </a:tcPr>
                 </a:tc>
               </a:tr>
@@ -27464,14 +27464,14 @@
                     </a:p>
                   </a:txBody>
                   <a:tcPr>
-                    <a:solidFill>
-                      <a:srgbClr val="FFFFFF"/>
-                    </a:solidFill>
                     <a:lnB w="9525" cap="flat">
                       <a:solidFill>
                         <a:srgbClr val="E7E7E5"/>
                       </a:solidFill>
                     </a:lnB>
+                    <a:solidFill>
+                      <a:srgbClr val="FFFFFF"/>
+                    </a:solidFill>
                   </a:tcPr>
                 </a:tc>
                 <a:tc>
@@ -27496,14 +27496,14 @@
                     </a:p>
                   </a:txBody>
                   <a:tcPr>
-                    <a:solidFill>
-                      <a:srgbClr val="FFFFFF"/>
-                    </a:solidFill>
                     <a:lnB w="9525" cap="flat">
                       <a:solidFill>
                         <a:srgbClr val="E7E7E5"/>
                       </a:solidFill>
                     </a:lnB>
+                    <a:solidFill>
+                      <a:srgbClr val="FFFFFF"/>
+                    </a:solidFill>
                   </a:tcPr>
                 </a:tc>
                 <a:tc>
@@ -27528,14 +27528,14 @@
                     </a:p>
                   </a:txBody>
                   <a:tcPr>
-                    <a:solidFill>
-                      <a:srgbClr val="FFFFFF"/>
-                    </a:solidFill>
                     <a:lnB w="9525" cap="flat">
                       <a:solidFill>
                         <a:srgbClr val="E7E7E5"/>
                       </a:solidFill>
                     </a:lnB>
+                    <a:solidFill>
+                      <a:srgbClr val="FFFFFF"/>
+                    </a:solidFill>
                   </a:tcPr>
                 </a:tc>
                 <a:tc>
@@ -27560,14 +27560,14 @@
                     </a:p>
                   </a:txBody>
                   <a:tcPr>
-                    <a:solidFill>
-                      <a:srgbClr val="FFFFFF"/>
-                    </a:solidFill>
                     <a:lnB w="9525" cap="flat">
                       <a:solidFill>
                         <a:srgbClr val="E7E7E5"/>
                       </a:solidFill>
                     </a:lnB>
+                    <a:solidFill>
+                      <a:srgbClr val="FFFFFF"/>
+                    </a:solidFill>
                   </a:tcPr>
                 </a:tc>
               </a:tr>
@@ -27594,14 +27594,14 @@
                     </a:p>
                   </a:txBody>
                   <a:tcPr>
-                    <a:solidFill>
-                      <a:srgbClr val="FFFFFF"/>
-                    </a:solidFill>
                     <a:lnB w="9525" cap="flat">
                       <a:solidFill>
                         <a:srgbClr val="E7E7E5"/>
                       </a:solidFill>
                     </a:lnB>
+                    <a:solidFill>
+                      <a:srgbClr val="FFFFFF"/>
+                    </a:solidFill>
                   </a:tcPr>
                 </a:tc>
                 <a:tc>
@@ -27626,14 +27626,14 @@
                     </a:p>
                   </a:txBody>
                   <a:tcPr>
-                    <a:solidFill>
-                      <a:srgbClr val="FFFFFF"/>
-                    </a:solidFill>
                     <a:lnB w="9525" cap="flat">
                       <a:solidFill>
                         <a:srgbClr val="E7E7E5"/>
                       </a:solidFill>
                     </a:lnB>
+                    <a:solidFill>
+                      <a:srgbClr val="FFFFFF"/>
+                    </a:solidFill>
                   </a:tcPr>
                 </a:tc>
                 <a:tc>
@@ -27658,14 +27658,14 @@
                     </a:p>
                   </a:txBody>
                   <a:tcPr>
-                    <a:solidFill>
-                      <a:srgbClr val="FFFFFF"/>
-                    </a:solidFill>
                     <a:lnB w="9525" cap="flat">
                       <a:solidFill>
                         <a:srgbClr val="E7E7E5"/>
                       </a:solidFill>
                     </a:lnB>
+                    <a:solidFill>
+                      <a:srgbClr val="FFFFFF"/>
+                    </a:solidFill>
                   </a:tcPr>
                 </a:tc>
                 <a:tc>
@@ -27690,14 +27690,14 @@
                     </a:p>
                   </a:txBody>
                   <a:tcPr>
-                    <a:solidFill>
-                      <a:srgbClr val="FFFFFF"/>
-                    </a:solidFill>
                     <a:lnB w="9525" cap="flat">
                       <a:solidFill>
                         <a:srgbClr val="E7E7E5"/>
                       </a:solidFill>
                     </a:lnB>
+                    <a:solidFill>
+                      <a:srgbClr val="FFFFFF"/>
+                    </a:solidFill>
                   </a:tcPr>
                 </a:tc>
               </a:tr>
@@ -27724,14 +27724,14 @@
                     </a:p>
                   </a:txBody>
                   <a:tcPr>
-                    <a:solidFill>
-                      <a:srgbClr val="FFFFFF"/>
-                    </a:solidFill>
                     <a:lnB w="9525" cap="flat">
                       <a:solidFill>
                         <a:srgbClr val="E7E7E5"/>
                       </a:solidFill>
                     </a:lnB>
+                    <a:solidFill>
+                      <a:srgbClr val="FFFFFF"/>
+                    </a:solidFill>
                   </a:tcPr>
                 </a:tc>
                 <a:tc>
@@ -27756,14 +27756,14 @@
                     </a:p>
                   </a:txBody>
                   <a:tcPr>
-                    <a:solidFill>
-                      <a:srgbClr val="FFFFFF"/>
-                    </a:solidFill>
                     <a:lnB w="9525" cap="flat">
                       <a:solidFill>
                         <a:srgbClr val="E7E7E5"/>
                       </a:solidFill>
                     </a:lnB>
+                    <a:solidFill>
+                      <a:srgbClr val="FFFFFF"/>
+                    </a:solidFill>
                   </a:tcPr>
                 </a:tc>
                 <a:tc>
@@ -27788,14 +27788,14 @@
                     </a:p>
                   </a:txBody>
                   <a:tcPr>
-                    <a:solidFill>
-                      <a:srgbClr val="FFFFFF"/>
-                    </a:solidFill>
                     <a:lnB w="9525" cap="flat">
                       <a:solidFill>
                         <a:srgbClr val="E7E7E5"/>
                       </a:solidFill>
                     </a:lnB>
+                    <a:solidFill>
+                      <a:srgbClr val="FFFFFF"/>
+                    </a:solidFill>
                   </a:tcPr>
                 </a:tc>
                 <a:tc>
@@ -27820,14 +27820,14 @@
                     </a:p>
                   </a:txBody>
                   <a:tcPr>
-                    <a:solidFill>
-                      <a:srgbClr val="FFFFFF"/>
-                    </a:solidFill>
                     <a:lnB w="9525" cap="flat">
                       <a:solidFill>
                         <a:srgbClr val="E7E7E5"/>
                       </a:solidFill>
                     </a:lnB>
+                    <a:solidFill>
+                      <a:srgbClr val="FFFFFF"/>
+                    </a:solidFill>
                   </a:tcPr>
                 </a:tc>
               </a:tr>
@@ -27854,14 +27854,14 @@
                     </a:p>
                   </a:txBody>
                   <a:tcPr>
-                    <a:solidFill>
-                      <a:srgbClr val="FFFFFF"/>
-                    </a:solidFill>
                     <a:lnB w="9525" cap="flat">
                       <a:solidFill>
                         <a:srgbClr val="E7E7E5"/>
                       </a:solidFill>
                     </a:lnB>
+                    <a:solidFill>
+                      <a:srgbClr val="FFFFFF"/>
+                    </a:solidFill>
                   </a:tcPr>
                 </a:tc>
                 <a:tc>
@@ -27886,14 +27886,14 @@
                     </a:p>
                   </a:txBody>
                   <a:tcPr>
-                    <a:solidFill>
-                      <a:srgbClr val="FFFFFF"/>
-                    </a:solidFill>
                     <a:lnB w="9525" cap="flat">
                       <a:solidFill>
                         <a:srgbClr val="E7E7E5"/>
                       </a:solidFill>
                     </a:lnB>
+                    <a:solidFill>
+                      <a:srgbClr val="FFFFFF"/>
+                    </a:solidFill>
                   </a:tcPr>
                 </a:tc>
                 <a:tc>
@@ -27918,14 +27918,14 @@
                     </a:p>
                   </a:txBody>
                   <a:tcPr>
-                    <a:solidFill>
-                      <a:srgbClr val="FFFFFF"/>
-                    </a:solidFill>
                     <a:lnB w="9525" cap="flat">
                       <a:solidFill>
                         <a:srgbClr val="E7E7E5"/>
                       </a:solidFill>
                     </a:lnB>
+                    <a:solidFill>
+                      <a:srgbClr val="FFFFFF"/>
+                    </a:solidFill>
                   </a:tcPr>
                 </a:tc>
                 <a:tc>
@@ -27950,14 +27950,14 @@
                     </a:p>
                   </a:txBody>
                   <a:tcPr>
-                    <a:solidFill>
-                      <a:srgbClr val="FFFFFF"/>
-                    </a:solidFill>
                     <a:lnB w="9525" cap="flat">
                       <a:solidFill>
                         <a:srgbClr val="E7E7E5"/>
                       </a:solidFill>
                     </a:lnB>
+                    <a:solidFill>
+                      <a:srgbClr val="FFFFFF"/>
+                    </a:solidFill>
                   </a:tcPr>
                 </a:tc>
               </a:tr>
@@ -27984,14 +27984,14 @@
                     </a:p>
                   </a:txBody>
                   <a:tcPr>
-                    <a:solidFill>
-                      <a:srgbClr val="FFFFFF"/>
-                    </a:solidFill>
                     <a:lnB w="9525" cap="flat">
                       <a:solidFill>
                         <a:srgbClr val="E7E7E5"/>
                       </a:solidFill>
                     </a:lnB>
+                    <a:solidFill>
+                      <a:srgbClr val="FFFFFF"/>
+                    </a:solidFill>
                   </a:tcPr>
                 </a:tc>
                 <a:tc>
@@ -28016,14 +28016,14 @@
                     </a:p>
                   </a:txBody>
                   <a:tcPr>
-                    <a:solidFill>
-                      <a:srgbClr val="FFFFFF"/>
-                    </a:solidFill>
                     <a:lnB w="9525" cap="flat">
                       <a:solidFill>
                         <a:srgbClr val="E7E7E5"/>
                       </a:solidFill>
                     </a:lnB>
+                    <a:solidFill>
+                      <a:srgbClr val="FFFFFF"/>
+                    </a:solidFill>
                   </a:tcPr>
                 </a:tc>
                 <a:tc>
@@ -28048,14 +28048,14 @@
                     </a:p>
                   </a:txBody>
                   <a:tcPr>
-                    <a:solidFill>
-                      <a:srgbClr val="FFFFFF"/>
-                    </a:solidFill>
                     <a:lnB w="9525" cap="flat">
                       <a:solidFill>
                         <a:srgbClr val="E7E7E5"/>
                       </a:solidFill>
                     </a:lnB>
+                    <a:solidFill>
+                      <a:srgbClr val="FFFFFF"/>
+                    </a:solidFill>
                   </a:tcPr>
                 </a:tc>
                 <a:tc>
@@ -28080,14 +28080,14 @@
                     </a:p>
                   </a:txBody>
                   <a:tcPr>
-                    <a:solidFill>
-                      <a:srgbClr val="FFFFFF"/>
-                    </a:solidFill>
                     <a:lnB w="9525" cap="flat">
                       <a:solidFill>
                         <a:srgbClr val="E7E7E5"/>
                       </a:solidFill>
                     </a:lnB>
+                    <a:solidFill>
+                      <a:srgbClr val="FFFFFF"/>
+                    </a:solidFill>
                   </a:tcPr>
                 </a:tc>
               </a:tr>
@@ -30777,14 +30777,14 @@
                     </a:p>
                   </a:txBody>
                   <a:tcPr>
-                    <a:solidFill>
-                      <a:srgbClr val="FFFFFF"/>
-                    </a:solidFill>
                     <a:lnB w="9525" cap="flat">
                       <a:solidFill>
                         <a:srgbClr val="E7E7E5"/>
                       </a:solidFill>
                     </a:lnB>
+                    <a:solidFill>
+                      <a:srgbClr val="FFFFFF"/>
+                    </a:solidFill>
                   </a:tcPr>
                 </a:tc>
                 <a:tc>
@@ -30804,14 +30804,14 @@
                     </a:p>
                   </a:txBody>
                   <a:tcPr>
-                    <a:solidFill>
-                      <a:srgbClr val="FFFFFF"/>
-                    </a:solidFill>
                     <a:lnB w="9525" cap="flat">
                       <a:solidFill>
                         <a:srgbClr val="E7E7E5"/>
                       </a:solidFill>
                     </a:lnB>
+                    <a:solidFill>
+                      <a:srgbClr val="FFFFFF"/>
+                    </a:solidFill>
                   </a:tcPr>
                 </a:tc>
                 <a:tc>
@@ -30831,14 +30831,14 @@
                     </a:p>
                   </a:txBody>
                   <a:tcPr>
-                    <a:solidFill>
-                      <a:srgbClr val="FFFFFF"/>
-                    </a:solidFill>
                     <a:lnB w="9525" cap="flat">
                       <a:solidFill>
                         <a:srgbClr val="E7E7E5"/>
                       </a:solidFill>
                     </a:lnB>
+                    <a:solidFill>
+                      <a:srgbClr val="FFFFFF"/>
+                    </a:solidFill>
                   </a:tcPr>
                 </a:tc>
                 <a:tc>
@@ -30858,14 +30858,14 @@
                     </a:p>
                   </a:txBody>
                   <a:tcPr>
-                    <a:solidFill>
-                      <a:srgbClr val="FFFFFF"/>
-                    </a:solidFill>
                     <a:lnB w="9525" cap="flat">
                       <a:solidFill>
                         <a:srgbClr val="E7E7E5"/>
                       </a:solidFill>
                     </a:lnB>
+                    <a:solidFill>
+                      <a:srgbClr val="FFFFFF"/>
+                    </a:solidFill>
                   </a:tcPr>
                 </a:tc>
               </a:tr>
@@ -30892,14 +30892,14 @@
                     </a:p>
                   </a:txBody>
                   <a:tcPr>
-                    <a:solidFill>
-                      <a:srgbClr val="FFFFFF"/>
-                    </a:solidFill>
                     <a:lnB w="9525" cap="flat">
                       <a:solidFill>
                         <a:srgbClr val="E7E7E5"/>
                       </a:solidFill>
                     </a:lnB>
+                    <a:solidFill>
+                      <a:srgbClr val="FFFFFF"/>
+                    </a:solidFill>
                   </a:tcPr>
                 </a:tc>
                 <a:tc>
@@ -30924,14 +30924,14 @@
                     </a:p>
                   </a:txBody>
                   <a:tcPr>
-                    <a:solidFill>
-                      <a:srgbClr val="FFFFFF"/>
-                    </a:solidFill>
                     <a:lnB w="9525" cap="flat">
                       <a:solidFill>
                         <a:srgbClr val="E7E7E5"/>
                       </a:solidFill>
                     </a:lnB>
+                    <a:solidFill>
+                      <a:srgbClr val="FFFFFF"/>
+                    </a:solidFill>
                   </a:tcPr>
                 </a:tc>
                 <a:tc>
@@ -30956,14 +30956,14 @@
                     </a:p>
                   </a:txBody>
                   <a:tcPr>
-                    <a:solidFill>
-                      <a:srgbClr val="F2F8F6"/>
-                    </a:solidFill>
                     <a:lnB w="9525" cap="flat">
                       <a:solidFill>
                         <a:srgbClr val="E7E7E5"/>
                       </a:solidFill>
                     </a:lnB>
+                    <a:solidFill>
+                      <a:srgbClr val="F2F8F6"/>
+                    </a:solidFill>
                   </a:tcPr>
                 </a:tc>
                 <a:tc>
@@ -30988,14 +30988,14 @@
                     </a:p>
                   </a:txBody>
                   <a:tcPr>
-                    <a:solidFill>
-                      <a:srgbClr val="FFFFFF"/>
-                    </a:solidFill>
                     <a:lnB w="9525" cap="flat">
                       <a:solidFill>
                         <a:srgbClr val="E7E7E5"/>
                       </a:solidFill>
                     </a:lnB>
+                    <a:solidFill>
+                      <a:srgbClr val="FFFFFF"/>
+                    </a:solidFill>
                   </a:tcPr>
                 </a:tc>
               </a:tr>
@@ -31022,14 +31022,14 @@
                     </a:p>
                   </a:txBody>
                   <a:tcPr>
-                    <a:solidFill>
-                      <a:srgbClr val="FFFFFF"/>
-                    </a:solidFill>
                     <a:lnB w="9525" cap="flat">
                       <a:solidFill>
                         <a:srgbClr val="E7E7E5"/>
                       </a:solidFill>
                     </a:lnB>
+                    <a:solidFill>
+                      <a:srgbClr val="FFFFFF"/>
+                    </a:solidFill>
                   </a:tcPr>
                 </a:tc>
                 <a:tc>
@@ -31054,14 +31054,14 @@
                     </a:p>
                   </a:txBody>
                   <a:tcPr>
-                    <a:solidFill>
-                      <a:srgbClr val="FFFFFF"/>
-                    </a:solidFill>
                     <a:lnB w="9525" cap="flat">
                       <a:solidFill>
                         <a:srgbClr val="E7E7E5"/>
                       </a:solidFill>
                     </a:lnB>
+                    <a:solidFill>
+                      <a:srgbClr val="FFFFFF"/>
+                    </a:solidFill>
                   </a:tcPr>
                 </a:tc>
                 <a:tc>
@@ -31086,14 +31086,14 @@
                     </a:p>
                   </a:txBody>
                   <a:tcPr>
-                    <a:solidFill>
-                      <a:srgbClr val="F2F8F6"/>
-                    </a:solidFill>
                     <a:lnB w="9525" cap="flat">
                       <a:solidFill>
                         <a:srgbClr val="E7E7E5"/>
                       </a:solidFill>
                     </a:lnB>
+                    <a:solidFill>
+                      <a:srgbClr val="F2F8F6"/>
+                    </a:solidFill>
                   </a:tcPr>
                 </a:tc>
                 <a:tc>
@@ -31118,14 +31118,14 @@
                     </a:p>
                   </a:txBody>
                   <a:tcPr>
-                    <a:solidFill>
-                      <a:srgbClr val="FFFFFF"/>
-                    </a:solidFill>
                     <a:lnB w="9525" cap="flat">
                       <a:solidFill>
                         <a:srgbClr val="E7E7E5"/>
                       </a:solidFill>
                     </a:lnB>
+                    <a:solidFill>
+                      <a:srgbClr val="FFFFFF"/>
+                    </a:solidFill>
                   </a:tcPr>
                 </a:tc>
               </a:tr>
@@ -31152,14 +31152,14 @@
                     </a:p>
                   </a:txBody>
                   <a:tcPr>
-                    <a:solidFill>
-                      <a:srgbClr val="FFFFFF"/>
-                    </a:solidFill>
                     <a:lnB w="9525" cap="flat">
                       <a:solidFill>
                         <a:srgbClr val="E7E7E5"/>
                       </a:solidFill>
                     </a:lnB>
+                    <a:solidFill>
+                      <a:srgbClr val="FFFFFF"/>
+                    </a:solidFill>
                   </a:tcPr>
                 </a:tc>
                 <a:tc>
@@ -31184,14 +31184,14 @@
                     </a:p>
                   </a:txBody>
                   <a:tcPr>
-                    <a:solidFill>
-                      <a:srgbClr val="FFFFFF"/>
-                    </a:solidFill>
                     <a:lnB w="9525" cap="flat">
                       <a:solidFill>
                         <a:srgbClr val="E7E7E5"/>
                       </a:solidFill>
                     </a:lnB>
+                    <a:solidFill>
+                      <a:srgbClr val="FFFFFF"/>
+                    </a:solidFill>
                   </a:tcPr>
                 </a:tc>
                 <a:tc>
@@ -31216,14 +31216,14 @@
                     </a:p>
                   </a:txBody>
                   <a:tcPr>
-                    <a:solidFill>
-                      <a:srgbClr val="F2F8F6"/>
-                    </a:solidFill>
                     <a:lnB w="9525" cap="flat">
                       <a:solidFill>
                         <a:srgbClr val="E7E7E5"/>
                       </a:solidFill>
                     </a:lnB>
+                    <a:solidFill>
+                      <a:srgbClr val="F2F8F6"/>
+                    </a:solidFill>
                   </a:tcPr>
                 </a:tc>
                 <a:tc>
@@ -31248,14 +31248,14 @@
                     </a:p>
                   </a:txBody>
                   <a:tcPr>
-                    <a:solidFill>
-                      <a:srgbClr val="FFFFFF"/>
-                    </a:solidFill>
                     <a:lnB w="9525" cap="flat">
                       <a:solidFill>
                         <a:srgbClr val="E7E7E5"/>
                       </a:solidFill>
                     </a:lnB>
+                    <a:solidFill>
+                      <a:srgbClr val="FFFFFF"/>
+                    </a:solidFill>
                   </a:tcPr>
                 </a:tc>
               </a:tr>
@@ -31282,14 +31282,14 @@
                     </a:p>
                   </a:txBody>
                   <a:tcPr>
-                    <a:solidFill>
-                      <a:srgbClr val="FFFFFF"/>
-                    </a:solidFill>
                     <a:lnB w="9525" cap="flat">
                       <a:solidFill>
                         <a:srgbClr val="E7E7E5"/>
                       </a:solidFill>
                     </a:lnB>
+                    <a:solidFill>
+                      <a:srgbClr val="FFFFFF"/>
+                    </a:solidFill>
                   </a:tcPr>
                 </a:tc>
                 <a:tc>
@@ -31314,14 +31314,14 @@
                     </a:p>
                   </a:txBody>
                   <a:tcPr>
-                    <a:solidFill>
-                      <a:srgbClr val="FFFFFF"/>
-                    </a:solidFill>
                     <a:lnB w="9525" cap="flat">
                       <a:solidFill>
                         <a:srgbClr val="E7E7E5"/>
                       </a:solidFill>
                     </a:lnB>
+                    <a:solidFill>
+                      <a:srgbClr val="FFFFFF"/>
+                    </a:solidFill>
                   </a:tcPr>
                 </a:tc>
                 <a:tc>
@@ -31346,14 +31346,14 @@
                     </a:p>
                   </a:txBody>
                   <a:tcPr>
-                    <a:solidFill>
-                      <a:srgbClr val="F2F8F6"/>
-                    </a:solidFill>
                     <a:lnB w="9525" cap="flat">
                       <a:solidFill>
                         <a:srgbClr val="E7E7E5"/>
                       </a:solidFill>
                     </a:lnB>
+                    <a:solidFill>
+                      <a:srgbClr val="F2F8F6"/>
+                    </a:solidFill>
                   </a:tcPr>
                 </a:tc>
                 <a:tc>
@@ -31378,14 +31378,14 @@
                     </a:p>
                   </a:txBody>
                   <a:tcPr>
-                    <a:solidFill>
-                      <a:srgbClr val="FFFFFF"/>
-                    </a:solidFill>
                     <a:lnB w="9525" cap="flat">
                       <a:solidFill>
                         <a:srgbClr val="E7E7E5"/>
                       </a:solidFill>
                     </a:lnB>
+                    <a:solidFill>
+                      <a:srgbClr val="FFFFFF"/>
+                    </a:solidFill>
                   </a:tcPr>
                 </a:tc>
               </a:tr>
@@ -31412,14 +31412,14 @@
                     </a:p>
                   </a:txBody>
                   <a:tcPr>
-                    <a:solidFill>
-                      <a:srgbClr val="FFFFFF"/>
-                    </a:solidFill>
                     <a:lnB w="9525" cap="flat">
                       <a:solidFill>
                         <a:srgbClr val="E7E7E5"/>
                       </a:solidFill>
                     </a:lnB>
+                    <a:solidFill>
+                      <a:srgbClr val="FFFFFF"/>
+                    </a:solidFill>
                   </a:tcPr>
                 </a:tc>
                 <a:tc>
@@ -31444,14 +31444,14 @@
                     </a:p>
                   </a:txBody>
                   <a:tcPr>
-                    <a:solidFill>
-                      <a:srgbClr val="FFFFFF"/>
-                    </a:solidFill>
                     <a:lnB w="9525" cap="flat">
                       <a:solidFill>
                         <a:srgbClr val="E7E7E5"/>
                       </a:solidFill>
                     </a:lnB>
+                    <a:solidFill>
+                      <a:srgbClr val="FFFFFF"/>
+                    </a:solidFill>
                   </a:tcPr>
                 </a:tc>
                 <a:tc>
@@ -31476,14 +31476,14 @@
                     </a:p>
                   </a:txBody>
                   <a:tcPr>
-                    <a:solidFill>
-                      <a:srgbClr val="F2F8F6"/>
-                    </a:solidFill>
                     <a:lnB w="9525" cap="flat">
                       <a:solidFill>
                         <a:srgbClr val="E7E7E5"/>
                       </a:solidFill>
                     </a:lnB>
+                    <a:solidFill>
+                      <a:srgbClr val="F2F8F6"/>
+                    </a:solidFill>
                   </a:tcPr>
                 </a:tc>
                 <a:tc>
@@ -31508,14 +31508,14 @@
                     </a:p>
                   </a:txBody>
                   <a:tcPr>
-                    <a:solidFill>
-                      <a:srgbClr val="FFFFFF"/>
-                    </a:solidFill>
                     <a:lnB w="9525" cap="flat">
                       <a:solidFill>
                         <a:srgbClr val="E7E7E5"/>
                       </a:solidFill>
                     </a:lnB>
+                    <a:solidFill>
+                      <a:srgbClr val="FFFFFF"/>
+                    </a:solidFill>
                   </a:tcPr>
                 </a:tc>
               </a:tr>
@@ -31542,14 +31542,14 @@
                     </a:p>
                   </a:txBody>
                   <a:tcPr>
-                    <a:solidFill>
-                      <a:srgbClr val="FFFFFF"/>
-                    </a:solidFill>
                     <a:lnB w="9525" cap="flat">
                       <a:solidFill>
                         <a:srgbClr val="E7E7E5"/>
                       </a:solidFill>
                     </a:lnB>
+                    <a:solidFill>
+                      <a:srgbClr val="FFFFFF"/>
+                    </a:solidFill>
                   </a:tcPr>
                 </a:tc>
                 <a:tc>
@@ -31574,14 +31574,14 @@
                     </a:p>
                   </a:txBody>
                   <a:tcPr>
-                    <a:solidFill>
-                      <a:srgbClr val="FFFFFF"/>
-                    </a:solidFill>
                     <a:lnB w="9525" cap="flat">
                       <a:solidFill>
                         <a:srgbClr val="E7E7E5"/>
                       </a:solidFill>
                     </a:lnB>
+                    <a:solidFill>
+                      <a:srgbClr val="FFFFFF"/>
+                    </a:solidFill>
                   </a:tcPr>
                 </a:tc>
                 <a:tc>
@@ -31606,14 +31606,14 @@
                     </a:p>
                   </a:txBody>
                   <a:tcPr>
-                    <a:solidFill>
-                      <a:srgbClr val="F2F8F6"/>
-                    </a:solidFill>
                     <a:lnB w="9525" cap="flat">
                       <a:solidFill>
                         <a:srgbClr val="E7E7E5"/>
                       </a:solidFill>
                     </a:lnB>
+                    <a:solidFill>
+                      <a:srgbClr val="F2F8F6"/>
+                    </a:solidFill>
                   </a:tcPr>
                 </a:tc>
                 <a:tc>
@@ -31638,14 +31638,14 @@
                     </a:p>
                   </a:txBody>
                   <a:tcPr>
-                    <a:solidFill>
-                      <a:srgbClr val="FFFFFF"/>
-                    </a:solidFill>
                     <a:lnB w="9525" cap="flat">
                       <a:solidFill>
                         <a:srgbClr val="E7E7E5"/>
                       </a:solidFill>
                     </a:lnB>
+                    <a:solidFill>
+                      <a:srgbClr val="FFFFFF"/>
+                    </a:solidFill>
                   </a:tcPr>
                 </a:tc>
               </a:tr>
@@ -37695,9 +37695,6 @@
             <a:off x="792478" y="5333986"/>
             <a:ext cx="609598" cy="609598"/>
           </a:xfrm>
-          <a:prstGeom prst="rect">
-            <a:avLst/>
-          </a:prstGeom>
           <a:prstGeom prst="ellipse">
             <a:avLst/>
           </a:prstGeom>
@@ -37723,9 +37720,6 @@
             <a:off x="1536188" y="5333986"/>
             <a:ext cx="609598" cy="609598"/>
           </a:xfrm>
-          <a:prstGeom prst="rect">
-            <a:avLst/>
-          </a:prstGeom>
           <a:prstGeom prst="ellipse">
             <a:avLst/>
           </a:prstGeom>
@@ -37751,9 +37745,6 @@
             <a:off x="2279898" y="5333986"/>
             <a:ext cx="609598" cy="609598"/>
           </a:xfrm>
-          <a:prstGeom prst="rect">
-            <a:avLst/>
-          </a:prstGeom>
           <a:prstGeom prst="ellipse">
             <a:avLst/>
           </a:prstGeom>
@@ -37779,9 +37770,6 @@
             <a:off x="3023608" y="5333986"/>
             <a:ext cx="609598" cy="609598"/>
           </a:xfrm>
-          <a:prstGeom prst="rect">
-            <a:avLst/>
-          </a:prstGeom>
           <a:prstGeom prst="ellipse">
             <a:avLst/>
           </a:prstGeom>
@@ -37807,9 +37795,6 @@
             <a:off x="3767318" y="5333986"/>
             <a:ext cx="609598" cy="609598"/>
           </a:xfrm>
-          <a:prstGeom prst="rect">
-            <a:avLst/>
-          </a:prstGeom>
           <a:prstGeom prst="ellipse">
             <a:avLst/>
           </a:prstGeom>
@@ -37835,9 +37820,6 @@
             <a:off x="4511028" y="5333986"/>
             <a:ext cx="609598" cy="609598"/>
           </a:xfrm>
-          <a:prstGeom prst="rect">
-            <a:avLst/>
-          </a:prstGeom>
           <a:prstGeom prst="ellipse">
             <a:avLst/>
           </a:prstGeom>
@@ -37863,9 +37845,6 @@
             <a:off x="5254738" y="5333986"/>
             <a:ext cx="609598" cy="609598"/>
           </a:xfrm>
-          <a:prstGeom prst="rect">
-            <a:avLst/>
-          </a:prstGeom>
           <a:prstGeom prst="ellipse">
             <a:avLst/>
           </a:prstGeom>
@@ -37891,9 +37870,6 @@
             <a:off x="5998449" y="5333986"/>
             <a:ext cx="609598" cy="609598"/>
           </a:xfrm>
-          <a:prstGeom prst="rect">
-            <a:avLst/>
-          </a:prstGeom>
           <a:prstGeom prst="ellipse">
             <a:avLst/>
           </a:prstGeom>

</xml_diff>